<commit_message>
Redesign app for applicants and bring all docs up to date
- App: customer-facing LoanSense UI with a single decision, coarse
  likelihood, plain-language reasons and EMI summary; model internals
  only in an examiner view (?examiner=1); green theme in .streamlit/
- KNOWLEDGE_DOCUMENT.md rewritten for the 3-model, CV, engineered-feature
  version and merged with PROJECT_EXPLANATION.md (removed)
- PRESENTATION_SLIDES.md now generated from the deck by
  build_presentation.py; demo slide matches the new app
- Remove legacy src/data_preparation.py and unused old EDA plots
- README updated

Co-Authored-By: Claude Opus 5.5 <noreply@anthropic.com>
</commit_message>
<xml_diff>
--- a/docs/Loan_Approval_Presentation.pptx
+++ b/docs/Loan_Approval_Presentation.pptx
@@ -1119,7 +1119,7 @@
           <a:lstStyle/>
           <a:p>
             <a:r>
-              <a:t>Run the app live if allowed. Flip Credit History to 0 and show every model switching to REJECTED. That connects the demo to the feature-importance slide.</a:t>
+              <a:t>Run the app live if allowed. Flip the credit-history answer and show the decision change. Then open the examiner view (add ?examiner=1 to the URL) to show the three models' probabilities. Explain that applicants never see these: only a decision, simple reasons and their EMI.</a:t>
             </a:r>
           </a:p>
         </p:txBody>
@@ -5996,7 +5996,7 @@
                 </a:solidFill>
                 <a:latin typeface="Calibri"/>
               </a:rPr>
-              <a:t>Enter details</a:t>
+              <a:t>Simple application form</a:t>
             </a:r>
           </a:p>
         </p:txBody>
@@ -6035,7 +6035,7 @@
                 </a:solidFill>
                 <a:latin typeface="Calibri"/>
               </a:rPr>
-              <a:t>A form with the 11 inputs a bank officer would fill in</a:t>
+              <a:t>About you, income &amp; credit, loan details</a:t>
             </a:r>
           </a:p>
         </p:txBody>
@@ -6127,7 +6127,7 @@
                 </a:solidFill>
                 <a:latin typeface="Calibri"/>
               </a:rPr>
-              <a:t>3 models predict</a:t>
+              <a:t>Clear decision</a:t>
             </a:r>
           </a:p>
         </p:txBody>
@@ -6166,7 +6166,7 @@
                 </a:solidFill>
                 <a:latin typeface="Calibri"/>
               </a:rPr>
-              <a:t>Approved / Rejected with a confidence %; best model starred</a:t>
+              <a:t>Likely / not likely to be approved, with plain reasons and the EMI</a:t>
             </a:r>
           </a:p>
         </p:txBody>
@@ -6258,7 +6258,7 @@
                 </a:solidFill>
                 <a:latin typeface="Calibri"/>
               </a:rPr>
-              <a:t>See affordability</a:t>
+              <a:t>Internals stay hidden</a:t>
             </a:r>
           </a:p>
         </p:txBody>
@@ -6297,7 +6297,7 @@
                 </a:solidFill>
                 <a:latin typeface="Calibri"/>
               </a:rPr>
-              <a:t>Shows the EMI, income left after EMI and loan-to-income ratio</a:t>
+              <a:t>Model names and probabilities appear only in an examiner view (?examiner=1)</a:t>
             </a:r>
           </a:p>
         </p:txBody>
@@ -6430,7 +6430,7 @@
                 </a:solidFill>
                 <a:latin typeface="Calibri"/>
               </a:rPr>
-              <a:t>1. Keep the defaults → all 3 models APPROVE (LR 82%, RF 79%, DT 75%)</a:t>
+              <a:t>1. Keep the defaults → Likely to be approved (High)</a:t>
             </a:r>
           </a:p>
           <a:p>
@@ -6446,7 +6446,7 @@
                 </a:solidFill>
                 <a:latin typeface="Calibri"/>
               </a:rPr>
-              <a:t>2. Set credit history to 0 → all 3 REJECT</a:t>
+              <a:t>2. Answer "No" to repaying past loans → Not likely (Very low)</a:t>
             </a:r>
           </a:p>
           <a:p>
@@ -6462,7 +6462,7 @@
                 </a:solidFill>
                 <a:latin typeface="Calibri"/>
               </a:rPr>
-              <a:t>One toggle flips every model: credit history in action.</a:t>
+              <a:t>Open ?examiner=1 to show all 3 models agree.</a:t>
             </a:r>
           </a:p>
         </p:txBody>

</xml_diff>